<commit_message>
Complete Week 2 FinTech audit, fixes, and pre-push verification
</commit_message>
<xml_diff>
--- a/PPT/Slides/Week_2_FinTech_Domain_Software_Development_Fundamentals.pptx
+++ b/PPT/Slides/Week_2_FinTech_Domain_Software_Development_Fundamentals.pptx
@@ -5556,13 +5556,13 @@
           <a:p>
             <a:pPr algn="l"/>
             <a:r>
-              <a:rPr sz="1300" b="0">
+              <a:rPr sz="1300">
                 <a:solidFill>
                   <a:srgbClr val="536273"/>
                 </a:solidFill>
                 <a:latin typeface="Aptos"/>
               </a:rPr>
-              <a:t>No API key required. A live request must run on an internet-connected machine; the included CSV is an example row from the API docs, not a full live extraction.</a:t>
+              <a:t>No API key required. Live API extraction was verified via Python on 2026-10-22; fx_rates_api.json, fx_rates_api_response.json, and fx_rates_api.csv contain live reference rates from Frankfurter.</a:t>
             </a:r>
           </a:p>
         </p:txBody>

</xml_diff>